<commit_message>
docs: atualização da apresentação
</commit_message>
<xml_diff>
--- a/docs/Torre_de_Hanoi_FATEC_Apresentacao.pptx
+++ b/docs/Torre_de_Hanoi_FATEC_Apresentacao.pptx
@@ -310,7 +310,7 @@
           <a:p>
             <a:fld id="{5BCAD085-E8A6-8845-BD4E-CB4CCA059FC4}" type="datetimeFigureOut">
               <a:rPr lang="en-US" smtClean="0"/>
-              <a:t>9/27/2026</a:t>
+              <a:t>9/28/2026</a:t>
             </a:fld>
             <a:endParaRPr lang="en-US"/>
           </a:p>
@@ -480,7 +480,7 @@
           <a:p>
             <a:fld id="{5BCAD085-E8A6-8845-BD4E-CB4CCA059FC4}" type="datetimeFigureOut">
               <a:rPr lang="en-US" smtClean="0"/>
-              <a:t>9/27/2026</a:t>
+              <a:t>9/28/2026</a:t>
             </a:fld>
             <a:endParaRPr lang="en-US"/>
           </a:p>
@@ -660,7 +660,7 @@
           <a:p>
             <a:fld id="{5BCAD085-E8A6-8845-BD4E-CB4CCA059FC4}" type="datetimeFigureOut">
               <a:rPr lang="en-US" smtClean="0"/>
-              <a:t>9/27/2026</a:t>
+              <a:t>9/28/2026</a:t>
             </a:fld>
             <a:endParaRPr lang="en-US"/>
           </a:p>
@@ -830,7 +830,7 @@
           <a:p>
             <a:fld id="{5BCAD085-E8A6-8845-BD4E-CB4CCA059FC4}" type="datetimeFigureOut">
               <a:rPr lang="en-US" smtClean="0"/>
-              <a:t>9/27/2026</a:t>
+              <a:t>9/28/2026</a:t>
             </a:fld>
             <a:endParaRPr lang="en-US"/>
           </a:p>
@@ -1076,7 +1076,7 @@
           <a:p>
             <a:fld id="{5BCAD085-E8A6-8845-BD4E-CB4CCA059FC4}" type="datetimeFigureOut">
               <a:rPr lang="en-US" smtClean="0"/>
-              <a:t>9/27/2026</a:t>
+              <a:t>9/28/2026</a:t>
             </a:fld>
             <a:endParaRPr lang="en-US"/>
           </a:p>
@@ -1364,7 +1364,7 @@
           <a:p>
             <a:fld id="{5BCAD085-E8A6-8845-BD4E-CB4CCA059FC4}" type="datetimeFigureOut">
               <a:rPr lang="en-US" smtClean="0"/>
-              <a:t>9/27/2026</a:t>
+              <a:t>9/28/2026</a:t>
             </a:fld>
             <a:endParaRPr lang="en-US"/>
           </a:p>
@@ -1786,7 +1786,7 @@
           <a:p>
             <a:fld id="{5BCAD085-E8A6-8845-BD4E-CB4CCA059FC4}" type="datetimeFigureOut">
               <a:rPr lang="en-US" smtClean="0"/>
-              <a:t>9/27/2026</a:t>
+              <a:t>9/28/2026</a:t>
             </a:fld>
             <a:endParaRPr lang="en-US"/>
           </a:p>
@@ -1904,7 +1904,7 @@
           <a:p>
             <a:fld id="{5BCAD085-E8A6-8845-BD4E-CB4CCA059FC4}" type="datetimeFigureOut">
               <a:rPr lang="en-US" smtClean="0"/>
-              <a:t>9/27/2026</a:t>
+              <a:t>9/28/2026</a:t>
             </a:fld>
             <a:endParaRPr lang="en-US"/>
           </a:p>
@@ -1999,7 +1999,7 @@
           <a:p>
             <a:fld id="{5BCAD085-E8A6-8845-BD4E-CB4CCA059FC4}" type="datetimeFigureOut">
               <a:rPr lang="en-US" smtClean="0"/>
-              <a:t>9/27/2026</a:t>
+              <a:t>9/28/2026</a:t>
             </a:fld>
             <a:endParaRPr lang="en-US"/>
           </a:p>
@@ -2276,7 +2276,7 @@
           <a:p>
             <a:fld id="{5BCAD085-E8A6-8845-BD4E-CB4CCA059FC4}" type="datetimeFigureOut">
               <a:rPr lang="en-US" smtClean="0"/>
-              <a:t>9/27/2026</a:t>
+              <a:t>9/28/2026</a:t>
             </a:fld>
             <a:endParaRPr lang="en-US"/>
           </a:p>
@@ -2529,7 +2529,7 @@
           <a:p>
             <a:fld id="{5BCAD085-E8A6-8845-BD4E-CB4CCA059FC4}" type="datetimeFigureOut">
               <a:rPr lang="en-US" smtClean="0"/>
-              <a:t>9/27/2026</a:t>
+              <a:t>9/28/2026</a:t>
             </a:fld>
             <a:endParaRPr lang="en-US"/>
           </a:p>
@@ -2742,7 +2742,7 @@
           <a:p>
             <a:fld id="{5BCAD085-E8A6-8845-BD4E-CB4CCA059FC4}" type="datetimeFigureOut">
               <a:rPr lang="en-US" smtClean="0"/>
-              <a:t>9/27/2026</a:t>
+              <a:t>9/28/2026</a:t>
             </a:fld>
             <a:endParaRPr lang="en-US"/>
           </a:p>
@@ -3466,7 +3466,7 @@
         <p:spPr>
           <a:xfrm>
             <a:off x="3685032" y="3794760"/>
-            <a:ext cx="6858000" cy="1280160"/>
+            <a:ext cx="4680320" cy="948978"/>
           </a:xfrm>
           <a:prstGeom prst="rect">
             <a:avLst/>
@@ -3496,7 +3496,19 @@
             </a:r>
             <a:r>
               <a:rPr dirty="0"/>
-              <a:t> Augusto • Henrique Camargo</a:t>
+              <a:t> </a:t>
+            </a:r>
+            <a:r>
+              <a:rPr lang="pt-BR" dirty="0" smtClean="0"/>
+              <a:t>Ferreira </a:t>
+            </a:r>
+            <a:r>
+              <a:rPr dirty="0" smtClean="0"/>
+              <a:t>• </a:t>
+            </a:r>
+            <a:r>
+              <a:rPr dirty="0"/>
+              <a:t>Henrique Camargo</a:t>
             </a:r>
           </a:p>
           <a:p>
@@ -3823,8 +3835,8 @@
         </p:nvSpPr>
         <p:spPr>
           <a:xfrm>
-            <a:off x="1018324" y="1370794"/>
-            <a:ext cx="8840882" cy="4016484"/>
+            <a:off x="1018324" y="1916703"/>
+            <a:ext cx="8720657" cy="2970044"/>
           </a:xfrm>
           <a:prstGeom prst="rect">
             <a:avLst/>
@@ -4035,80 +4047,6 @@
           </a:p>
           <a:p>
             <a:endParaRPr lang="pt-BR" sz="1700" dirty="0">
-              <a:solidFill>
-                <a:srgbClr val="DAE7F6"/>
-              </a:solidFill>
-              <a:latin typeface="Consolas"/>
-            </a:endParaRPr>
-          </a:p>
-          <a:p>
-            <a:r>
-              <a:rPr lang="pt-BR" sz="1700" dirty="0" smtClean="0">
-                <a:solidFill>
-                  <a:srgbClr val="DAE7F6"/>
-                </a:solidFill>
-                <a:latin typeface="Consolas"/>
-              </a:rPr>
-              <a:t>Objetivo</a:t>
-            </a:r>
-          </a:p>
-          <a:p>
-            <a:endParaRPr lang="pt-BR" sz="1700" dirty="0">
-              <a:solidFill>
-                <a:srgbClr val="DAE7F6"/>
-              </a:solidFill>
-              <a:latin typeface="Consolas"/>
-            </a:endParaRPr>
-          </a:p>
-          <a:p>
-            <a:r>
-              <a:rPr lang="pt-BR" sz="1700" dirty="0" smtClean="0">
-                <a:solidFill>
-                  <a:srgbClr val="DAE7F6"/>
-                </a:solidFill>
-                <a:latin typeface="Consolas"/>
-              </a:rPr>
-              <a:t>Mover </a:t>
-            </a:r>
-            <a:r>
-              <a:rPr lang="pt-BR" sz="1700" dirty="0">
-                <a:solidFill>
-                  <a:srgbClr val="DAE7F6"/>
-                </a:solidFill>
-                <a:latin typeface="Consolas"/>
-              </a:rPr>
-              <a:t>todos os discos da origem para o destino, respeitando as regras </a:t>
-            </a:r>
-            <a:r>
-              <a:rPr lang="pt-BR" sz="1700" dirty="0" smtClean="0">
-                <a:solidFill>
-                  <a:srgbClr val="DAE7F6"/>
-                </a:solidFill>
-                <a:latin typeface="Consolas"/>
-              </a:rPr>
-              <a:t>do</a:t>
-            </a:r>
-          </a:p>
-          <a:p>
-            <a:r>
-              <a:rPr lang="pt-BR" sz="1700" dirty="0" smtClean="0">
-                <a:solidFill>
-                  <a:srgbClr val="DAE7F6"/>
-                </a:solidFill>
-                <a:latin typeface="Consolas"/>
-              </a:rPr>
-              <a:t> </a:t>
-            </a:r>
-            <a:r>
-              <a:rPr lang="pt-BR" sz="1700" dirty="0">
-                <a:solidFill>
-                  <a:srgbClr val="DAE7F6"/>
-                </a:solidFill>
-                <a:latin typeface="Consolas"/>
-              </a:rPr>
-              <a:t>problema.</a:t>
-            </a:r>
-            <a:endParaRPr sz="1700" dirty="0">
               <a:solidFill>
                 <a:srgbClr val="DAE7F6"/>
               </a:solidFill>
@@ -4248,7 +4186,7 @@
         </p:blipFill>
         <p:spPr bwMode="auto">
           <a:xfrm>
-            <a:off x="6229604" y="2718953"/>
+            <a:off x="6430731" y="3207636"/>
             <a:ext cx="4085179" cy="1798203"/>
           </a:xfrm>
           <a:prstGeom prst="rect">
@@ -4364,7 +4302,7 @@
         <p:spPr>
           <a:xfrm>
             <a:off x="640080" y="347472"/>
-            <a:ext cx="4809906" cy="523220"/>
+            <a:ext cx="3841116" cy="523220"/>
           </a:xfrm>
           <a:prstGeom prst="rect">
             <a:avLst/>
@@ -4396,40 +4334,13 @@
               <a:t>. </a:t>
             </a:r>
             <a:r>
-              <a:rPr sz="2800" b="1" dirty="0">
+              <a:rPr lang="pt-BR" sz="2800" b="1" dirty="0" smtClean="0">
                 <a:solidFill>
                   <a:srgbClr val="F8FAFC"/>
                 </a:solidFill>
                 <a:latin typeface="Aptos Display"/>
               </a:rPr>
-              <a:t>O </a:t>
-            </a:r>
-            <a:r>
-              <a:rPr sz="2800" b="1" dirty="0" err="1">
-                <a:solidFill>
-                  <a:srgbClr val="F8FAFC"/>
-                </a:solidFill>
-                <a:latin typeface="Aptos Display"/>
-              </a:rPr>
-              <a:t>que</a:t>
-            </a:r>
-            <a:r>
-              <a:rPr sz="2800" b="1" dirty="0">
-                <a:solidFill>
-                  <a:srgbClr val="F8FAFC"/>
-                </a:solidFill>
-                <a:latin typeface="Aptos Display"/>
-              </a:rPr>
-              <a:t> é a Torre de </a:t>
-            </a:r>
-            <a:r>
-              <a:rPr sz="2800" b="1" dirty="0" err="1">
-                <a:solidFill>
-                  <a:srgbClr val="F8FAFC"/>
-                </a:solidFill>
-                <a:latin typeface="Aptos Display"/>
-              </a:rPr>
-              <a:t>Hanói</a:t>
+              <a:t>Objetivos e Regras</a:t>
             </a:r>
             <a:endParaRPr sz="2800" b="1" dirty="0">
               <a:solidFill>
@@ -4621,13 +4532,211 @@
           <a:lstStyle/>
           <a:p>
             <a:r>
-              <a:rPr sz="1900">
+              <a:rPr sz="1900" dirty="0">
                 <a:solidFill>
                   <a:srgbClr val="E2EAF4"/>
                 </a:solidFill>
                 <a:latin typeface="Aptos"/>
               </a:rPr>
-              <a:t>Mover todos os discos do pino de origem para o pino de destino, usando um terceiro pino como auxiliar.</a:t>
+              <a:t>Mover </a:t>
+            </a:r>
+            <a:r>
+              <a:rPr sz="1900" dirty="0" err="1">
+                <a:solidFill>
+                  <a:srgbClr val="E2EAF4"/>
+                </a:solidFill>
+                <a:latin typeface="Aptos"/>
+              </a:rPr>
+              <a:t>todos</a:t>
+            </a:r>
+            <a:r>
+              <a:rPr sz="1900" dirty="0">
+                <a:solidFill>
+                  <a:srgbClr val="E2EAF4"/>
+                </a:solidFill>
+                <a:latin typeface="Aptos"/>
+              </a:rPr>
+              <a:t> </a:t>
+            </a:r>
+            <a:r>
+              <a:rPr sz="1900" dirty="0" err="1">
+                <a:solidFill>
+                  <a:srgbClr val="E2EAF4"/>
+                </a:solidFill>
+                <a:latin typeface="Aptos"/>
+              </a:rPr>
+              <a:t>os</a:t>
+            </a:r>
+            <a:r>
+              <a:rPr sz="1900" dirty="0">
+                <a:solidFill>
+                  <a:srgbClr val="E2EAF4"/>
+                </a:solidFill>
+                <a:latin typeface="Aptos"/>
+              </a:rPr>
+              <a:t> discos do </a:t>
+            </a:r>
+            <a:r>
+              <a:rPr sz="1900" dirty="0" err="1">
+                <a:solidFill>
+                  <a:srgbClr val="E2EAF4"/>
+                </a:solidFill>
+                <a:latin typeface="Aptos"/>
+              </a:rPr>
+              <a:t>pino</a:t>
+            </a:r>
+            <a:r>
+              <a:rPr sz="1900" dirty="0">
+                <a:solidFill>
+                  <a:srgbClr val="E2EAF4"/>
+                </a:solidFill>
+                <a:latin typeface="Aptos"/>
+              </a:rPr>
+              <a:t> de </a:t>
+            </a:r>
+            <a:r>
+              <a:rPr sz="1900" dirty="0" err="1">
+                <a:solidFill>
+                  <a:srgbClr val="E2EAF4"/>
+                </a:solidFill>
+                <a:latin typeface="Aptos"/>
+              </a:rPr>
+              <a:t>origem</a:t>
+            </a:r>
+            <a:r>
+              <a:rPr sz="1900" dirty="0">
+                <a:solidFill>
+                  <a:srgbClr val="E2EAF4"/>
+                </a:solidFill>
+                <a:latin typeface="Aptos"/>
+              </a:rPr>
+              <a:t> para o </a:t>
+            </a:r>
+            <a:r>
+              <a:rPr sz="1900" dirty="0" err="1">
+                <a:solidFill>
+                  <a:srgbClr val="E2EAF4"/>
+                </a:solidFill>
+                <a:latin typeface="Aptos"/>
+              </a:rPr>
+              <a:t>pino</a:t>
+            </a:r>
+            <a:r>
+              <a:rPr sz="1900" dirty="0">
+                <a:solidFill>
+                  <a:srgbClr val="E2EAF4"/>
+                </a:solidFill>
+                <a:latin typeface="Aptos"/>
+              </a:rPr>
+              <a:t> de </a:t>
+            </a:r>
+            <a:r>
+              <a:rPr sz="1900" dirty="0" err="1">
+                <a:solidFill>
+                  <a:srgbClr val="E2EAF4"/>
+                </a:solidFill>
+                <a:latin typeface="Aptos"/>
+              </a:rPr>
+              <a:t>destino</a:t>
+            </a:r>
+            <a:r>
+              <a:rPr sz="1900" dirty="0">
+                <a:solidFill>
+                  <a:srgbClr val="E2EAF4"/>
+                </a:solidFill>
+                <a:latin typeface="Aptos"/>
+              </a:rPr>
+              <a:t>, </a:t>
+            </a:r>
+            <a:r>
+              <a:rPr sz="1900" dirty="0" err="1">
+                <a:solidFill>
+                  <a:srgbClr val="E2EAF4"/>
+                </a:solidFill>
+                <a:latin typeface="Aptos"/>
+              </a:rPr>
+              <a:t>usando</a:t>
+            </a:r>
+            <a:r>
+              <a:rPr sz="1900" dirty="0">
+                <a:solidFill>
+                  <a:srgbClr val="E2EAF4"/>
+                </a:solidFill>
+                <a:latin typeface="Aptos"/>
+              </a:rPr>
+              <a:t> um </a:t>
+            </a:r>
+            <a:r>
+              <a:rPr sz="1900" dirty="0" err="1">
+                <a:solidFill>
+                  <a:srgbClr val="E2EAF4"/>
+                </a:solidFill>
+                <a:latin typeface="Aptos"/>
+              </a:rPr>
+              <a:t>terceiro</a:t>
+            </a:r>
+            <a:r>
+              <a:rPr sz="1900" dirty="0">
+                <a:solidFill>
+                  <a:srgbClr val="E2EAF4"/>
+                </a:solidFill>
+                <a:latin typeface="Aptos"/>
+              </a:rPr>
+              <a:t> </a:t>
+            </a:r>
+            <a:r>
+              <a:rPr sz="1900" dirty="0" err="1">
+                <a:solidFill>
+                  <a:srgbClr val="E2EAF4"/>
+                </a:solidFill>
+                <a:latin typeface="Aptos"/>
+              </a:rPr>
+              <a:t>pino</a:t>
+            </a:r>
+            <a:r>
+              <a:rPr sz="1900" dirty="0">
+                <a:solidFill>
+                  <a:srgbClr val="E2EAF4"/>
+                </a:solidFill>
+                <a:latin typeface="Aptos"/>
+              </a:rPr>
+              <a:t> </a:t>
+            </a:r>
+            <a:r>
+              <a:rPr sz="1900" dirty="0" err="1">
+                <a:solidFill>
+                  <a:srgbClr val="E2EAF4"/>
+                </a:solidFill>
+                <a:latin typeface="Aptos"/>
+              </a:rPr>
+              <a:t>como</a:t>
+            </a:r>
+            <a:r>
+              <a:rPr sz="1900" dirty="0">
+                <a:solidFill>
+                  <a:srgbClr val="E2EAF4"/>
+                </a:solidFill>
+                <a:latin typeface="Aptos"/>
+              </a:rPr>
+              <a:t> </a:t>
+            </a:r>
+            <a:r>
+              <a:rPr sz="1900" dirty="0" err="1">
+                <a:solidFill>
+                  <a:srgbClr val="E2EAF4"/>
+                </a:solidFill>
+                <a:latin typeface="Aptos"/>
+              </a:rPr>
+              <a:t>auxiliar</a:t>
+            </a:r>
+            <a:r>
+              <a:rPr sz="1900" dirty="0">
+                <a:solidFill>
+                  <a:srgbClr val="E2EAF4"/>
+                </a:solidFill>
+                <a:latin typeface="Aptos"/>
+              </a:rPr>
+              <a:t>.</a:t>
             </a:r>
           </a:p>
         </p:txBody>
@@ -6420,7 +6529,7 @@
         <p:spPr>
           <a:xfrm>
             <a:off x="640080" y="347472"/>
-            <a:ext cx="2180405" cy="523220"/>
+            <a:ext cx="2602059" cy="523220"/>
           </a:xfrm>
           <a:prstGeom prst="rect">
             <a:avLst/>
@@ -6452,22 +6561,13 @@
               <a:t>. </a:t>
             </a:r>
             <a:r>
-              <a:rPr sz="2800" b="1" dirty="0">
+              <a:rPr lang="pt-BR" sz="2800" b="1" dirty="0" smtClean="0">
                 <a:solidFill>
                   <a:srgbClr val="F8FAFC"/>
                 </a:solidFill>
                 <a:latin typeface="Aptos Display"/>
               </a:rPr>
-              <a:t>O </a:t>
-            </a:r>
-            <a:r>
-              <a:rPr sz="2800" b="1" dirty="0" err="1">
-                <a:solidFill>
-                  <a:srgbClr val="F8FAFC"/>
-                </a:solidFill>
-                <a:latin typeface="Aptos Display"/>
-              </a:rPr>
-              <a:t>projeto</a:t>
+              <a:t>A Aplicação</a:t>
             </a:r>
             <a:endParaRPr sz="2800" b="1" dirty="0">
               <a:solidFill>
@@ -7255,16 +7355,7 @@
                 </a:solidFill>
                 <a:latin typeface="Aptos Display"/>
               </a:rPr>
-              <a:t>Implementação em </a:t>
-            </a:r>
-            <a:r>
-              <a:rPr lang="pt-BR" sz="2800" b="1" dirty="0" err="1">
-                <a:solidFill>
-                  <a:srgbClr val="F8FAFC"/>
-                </a:solidFill>
-                <a:latin typeface="Aptos Display"/>
-              </a:rPr>
-              <a:t>TypeScript</a:t>
+              <a:t>Implementação em TypeScript</a:t>
             </a:r>
             <a:endParaRPr sz="2800" b="1" dirty="0">
               <a:solidFill>
@@ -7284,7 +7375,7 @@
         <p:spPr>
           <a:xfrm>
             <a:off x="658368" y="914400"/>
-            <a:ext cx="10698480" cy="365760"/>
+            <a:ext cx="2746714" cy="292388"/>
           </a:xfrm>
           <a:prstGeom prst="rect">
             <a:avLst/>
@@ -7298,112 +7389,13 @@
           <a:lstStyle/>
           <a:p>
             <a:r>
-              <a:rPr sz="1300" dirty="0">
+              <a:rPr lang="pt-BR" sz="1300" dirty="0" smtClean="0">
                 <a:solidFill>
                   <a:srgbClr val="A0B4CD"/>
                 </a:solidFill>
                 <a:latin typeface="Aptos"/>
               </a:rPr>
-              <a:t>A </a:t>
-            </a:r>
-            <a:r>
-              <a:rPr sz="1300" dirty="0" err="1">
-                <a:solidFill>
-                  <a:srgbClr val="A0B4CD"/>
-                </a:solidFill>
-                <a:latin typeface="Aptos"/>
-              </a:rPr>
-              <a:t>solução</a:t>
-            </a:r>
-            <a:r>
-              <a:rPr sz="1300" dirty="0">
-                <a:solidFill>
-                  <a:srgbClr val="A0B4CD"/>
-                </a:solidFill>
-                <a:latin typeface="Aptos"/>
-              </a:rPr>
-              <a:t> </a:t>
-            </a:r>
-            <a:r>
-              <a:rPr sz="1300" dirty="0" err="1">
-                <a:solidFill>
-                  <a:srgbClr val="A0B4CD"/>
-                </a:solidFill>
-                <a:latin typeface="Aptos"/>
-              </a:rPr>
-              <a:t>reduz</a:t>
-            </a:r>
-            <a:r>
-              <a:rPr sz="1300" dirty="0">
-                <a:solidFill>
-                  <a:srgbClr val="A0B4CD"/>
-                </a:solidFill>
-                <a:latin typeface="Aptos"/>
-              </a:rPr>
-              <a:t> o </a:t>
-            </a:r>
-            <a:r>
-              <a:rPr sz="1300" dirty="0" err="1">
-                <a:solidFill>
-                  <a:srgbClr val="A0B4CD"/>
-                </a:solidFill>
-                <a:latin typeface="Aptos"/>
-              </a:rPr>
-              <a:t>problema</a:t>
-            </a:r>
-            <a:r>
-              <a:rPr sz="1300" dirty="0">
-                <a:solidFill>
-                  <a:srgbClr val="A0B4CD"/>
-                </a:solidFill>
-                <a:latin typeface="Aptos"/>
-              </a:rPr>
-              <a:t> para </a:t>
-            </a:r>
-            <a:r>
-              <a:rPr sz="1300" dirty="0" err="1">
-                <a:solidFill>
-                  <a:srgbClr val="A0B4CD"/>
-                </a:solidFill>
-                <a:latin typeface="Aptos"/>
-              </a:rPr>
-              <a:t>uma</a:t>
-            </a:r>
-            <a:r>
-              <a:rPr sz="1300" dirty="0">
-                <a:solidFill>
-                  <a:srgbClr val="A0B4CD"/>
-                </a:solidFill>
-                <a:latin typeface="Aptos"/>
-              </a:rPr>
-              <a:t> Torre de </a:t>
-            </a:r>
-            <a:r>
-              <a:rPr sz="1300" dirty="0" err="1">
-                <a:solidFill>
-                  <a:srgbClr val="A0B4CD"/>
-                </a:solidFill>
-                <a:latin typeface="Aptos"/>
-              </a:rPr>
-              <a:t>Hanói</a:t>
-            </a:r>
-            <a:r>
-              <a:rPr sz="1300" dirty="0">
-                <a:solidFill>
-                  <a:srgbClr val="A0B4CD"/>
-                </a:solidFill>
-                <a:latin typeface="Aptos"/>
-              </a:rPr>
-              <a:t> </a:t>
-            </a:r>
-            <a:r>
-              <a:rPr sz="1300" dirty="0" err="1">
-                <a:solidFill>
-                  <a:srgbClr val="A0B4CD"/>
-                </a:solidFill>
-                <a:latin typeface="Aptos"/>
-              </a:rPr>
-              <a:t>menor</a:t>
+              <a:t>Código usado na nossa Aplicação.</a:t>
             </a:r>
             <a:endParaRPr sz="1300" dirty="0">
               <a:solidFill>
@@ -7416,488 +7408,14 @@
       </p:sp>
       <p:sp>
         <p:nvSpPr>
-          <p:cNvPr id="5" name="Rounded Rectangle 4"/>
-          <p:cNvSpPr/>
-          <p:nvPr/>
-        </p:nvSpPr>
-        <p:spPr>
-          <a:xfrm>
-            <a:off x="640080" y="1325880"/>
-            <a:ext cx="3429000" cy="1143000"/>
-          </a:xfrm>
-          <a:prstGeom prst="roundRect">
-            <a:avLst/>
-          </a:prstGeom>
-          <a:solidFill>
-            <a:srgbClr val="102A4E"/>
-          </a:solidFill>
-          <a:ln w="12700">
-            <a:solidFill>
-              <a:srgbClr val="274C78"/>
-            </a:solidFill>
-          </a:ln>
-        </p:spPr>
-        <p:style>
-          <a:lnRef idx="1">
-            <a:schemeClr val="accent1"/>
-          </a:lnRef>
-          <a:fillRef idx="3">
-            <a:schemeClr val="accent1"/>
-          </a:fillRef>
-          <a:effectRef idx="2">
-            <a:schemeClr val="accent1"/>
-          </a:effectRef>
-          <a:fontRef idx="minor">
-            <a:schemeClr val="lt1"/>
-          </a:fontRef>
-        </p:style>
-        <p:txBody>
-          <a:bodyPr rtlCol="0" anchor="ctr"/>
-          <a:lstStyle/>
-          <a:p>
-            <a:pPr algn="ctr"/>
-            <a:endParaRPr/>
-          </a:p>
-        </p:txBody>
-      </p:sp>
-      <p:sp>
-        <p:nvSpPr>
-          <p:cNvPr id="6" name="Rectangle 5"/>
-          <p:cNvSpPr/>
-          <p:nvPr/>
-        </p:nvSpPr>
-        <p:spPr>
-          <a:xfrm>
-            <a:off x="640080" y="1325880"/>
-            <a:ext cx="64008" cy="1143000"/>
-          </a:xfrm>
-          <a:prstGeom prst="rect">
-            <a:avLst/>
-          </a:prstGeom>
-          <a:solidFill>
-            <a:srgbClr val="2D84FF"/>
-          </a:solidFill>
-          <a:ln>
-            <a:noFill/>
-          </a:ln>
-        </p:spPr>
-        <p:style>
-          <a:lnRef idx="1">
-            <a:schemeClr val="accent1"/>
-          </a:lnRef>
-          <a:fillRef idx="3">
-            <a:schemeClr val="accent1"/>
-          </a:fillRef>
-          <a:effectRef idx="2">
-            <a:schemeClr val="accent1"/>
-          </a:effectRef>
-          <a:fontRef idx="minor">
-            <a:schemeClr val="lt1"/>
-          </a:fontRef>
-        </p:style>
-        <p:txBody>
-          <a:bodyPr rtlCol="0" anchor="ctr"/>
-          <a:lstStyle/>
-          <a:p>
-            <a:pPr algn="ctr"/>
-            <a:endParaRPr/>
-          </a:p>
-        </p:txBody>
-      </p:sp>
-      <p:sp>
-        <p:nvSpPr>
-          <p:cNvPr id="7" name="TextBox 6"/>
-          <p:cNvSpPr txBox="1"/>
-          <p:nvPr/>
-        </p:nvSpPr>
-        <p:spPr>
-          <a:xfrm>
-            <a:off x="841247" y="1490472"/>
-            <a:ext cx="3044952" cy="365760"/>
-          </a:xfrm>
-          <a:prstGeom prst="rect">
-            <a:avLst/>
-          </a:prstGeom>
-          <a:noFill/>
-        </p:spPr>
-        <p:txBody>
-          <a:bodyPr wrap="none">
-            <a:spAutoFit/>
-          </a:bodyPr>
-          <a:lstStyle/>
-          <a:p>
-            <a:r>
-              <a:rPr sz="1700" b="1">
-                <a:solidFill>
-                  <a:srgbClr val="F8FAFC"/>
-                </a:solidFill>
-                <a:latin typeface="Aptos"/>
-              </a:rPr>
-              <a:t>1. Caso base</a:t>
-            </a:r>
-          </a:p>
-        </p:txBody>
-      </p:sp>
-      <p:sp>
-        <p:nvSpPr>
-          <p:cNvPr id="8" name="TextBox 7"/>
-          <p:cNvSpPr txBox="1"/>
-          <p:nvPr/>
-        </p:nvSpPr>
-        <p:spPr>
-          <a:xfrm>
-            <a:off x="841247" y="1947672"/>
-            <a:ext cx="3044952" cy="393192"/>
-          </a:xfrm>
-          <a:prstGeom prst="rect">
-            <a:avLst/>
-          </a:prstGeom>
-          <a:noFill/>
-        </p:spPr>
-        <p:txBody>
-          <a:bodyPr wrap="square">
-            <a:spAutoFit/>
-          </a:bodyPr>
-          <a:lstStyle/>
-          <a:p>
-            <a:r>
-              <a:rPr sz="1500">
-                <a:solidFill>
-                  <a:srgbClr val="E2EAF4"/>
-                </a:solidFill>
-                <a:latin typeface="Aptos"/>
-              </a:rPr>
-              <a:t>Se n = 1, move o disco diretamente.</a:t>
-            </a:r>
-          </a:p>
-        </p:txBody>
-      </p:sp>
-      <p:sp>
-        <p:nvSpPr>
-          <p:cNvPr id="9" name="Rounded Rectangle 8"/>
-          <p:cNvSpPr/>
-          <p:nvPr/>
-        </p:nvSpPr>
-        <p:spPr>
-          <a:xfrm>
-            <a:off x="640080" y="2697480"/>
-            <a:ext cx="3429000" cy="1325880"/>
-          </a:xfrm>
-          <a:prstGeom prst="roundRect">
-            <a:avLst/>
-          </a:prstGeom>
-          <a:solidFill>
-            <a:srgbClr val="102A4E"/>
-          </a:solidFill>
-          <a:ln w="12700">
-            <a:solidFill>
-              <a:srgbClr val="274C78"/>
-            </a:solidFill>
-          </a:ln>
-        </p:spPr>
-        <p:style>
-          <a:lnRef idx="1">
-            <a:schemeClr val="accent1"/>
-          </a:lnRef>
-          <a:fillRef idx="3">
-            <a:schemeClr val="accent1"/>
-          </a:fillRef>
-          <a:effectRef idx="2">
-            <a:schemeClr val="accent1"/>
-          </a:effectRef>
-          <a:fontRef idx="minor">
-            <a:schemeClr val="lt1"/>
-          </a:fontRef>
-        </p:style>
-        <p:txBody>
-          <a:bodyPr rtlCol="0" anchor="ctr"/>
-          <a:lstStyle/>
-          <a:p>
-            <a:pPr algn="ctr"/>
-            <a:endParaRPr/>
-          </a:p>
-        </p:txBody>
-      </p:sp>
-      <p:sp>
-        <p:nvSpPr>
-          <p:cNvPr id="10" name="Rectangle 9"/>
-          <p:cNvSpPr/>
-          <p:nvPr/>
-        </p:nvSpPr>
-        <p:spPr>
-          <a:xfrm>
-            <a:off x="640080" y="2697480"/>
-            <a:ext cx="64008" cy="1325880"/>
-          </a:xfrm>
-          <a:prstGeom prst="rect">
-            <a:avLst/>
-          </a:prstGeom>
-          <a:solidFill>
-            <a:srgbClr val="2DBE78"/>
-          </a:solidFill>
-          <a:ln>
-            <a:noFill/>
-          </a:ln>
-        </p:spPr>
-        <p:style>
-          <a:lnRef idx="1">
-            <a:schemeClr val="accent1"/>
-          </a:lnRef>
-          <a:fillRef idx="3">
-            <a:schemeClr val="accent1"/>
-          </a:fillRef>
-          <a:effectRef idx="2">
-            <a:schemeClr val="accent1"/>
-          </a:effectRef>
-          <a:fontRef idx="minor">
-            <a:schemeClr val="lt1"/>
-          </a:fontRef>
-        </p:style>
-        <p:txBody>
-          <a:bodyPr rtlCol="0" anchor="ctr"/>
-          <a:lstStyle/>
-          <a:p>
-            <a:pPr algn="ctr"/>
-            <a:endParaRPr/>
-          </a:p>
-        </p:txBody>
-      </p:sp>
-      <p:sp>
-        <p:nvSpPr>
-          <p:cNvPr id="11" name="TextBox 10"/>
-          <p:cNvSpPr txBox="1"/>
-          <p:nvPr/>
-        </p:nvSpPr>
-        <p:spPr>
-          <a:xfrm>
-            <a:off x="841247" y="2862072"/>
-            <a:ext cx="3044952" cy="365760"/>
-          </a:xfrm>
-          <a:prstGeom prst="rect">
-            <a:avLst/>
-          </a:prstGeom>
-          <a:noFill/>
-        </p:spPr>
-        <p:txBody>
-          <a:bodyPr wrap="none">
-            <a:spAutoFit/>
-          </a:bodyPr>
-          <a:lstStyle/>
-          <a:p>
-            <a:r>
-              <a:rPr sz="1700" b="1">
-                <a:solidFill>
-                  <a:srgbClr val="F8FAFC"/>
-                </a:solidFill>
-                <a:latin typeface="Aptos"/>
-              </a:rPr>
-              <a:t>2. Recursão</a:t>
-            </a:r>
-          </a:p>
-        </p:txBody>
-      </p:sp>
-      <p:sp>
-        <p:nvSpPr>
-          <p:cNvPr id="12" name="TextBox 11"/>
-          <p:cNvSpPr txBox="1"/>
-          <p:nvPr/>
-        </p:nvSpPr>
-        <p:spPr>
-          <a:xfrm>
-            <a:off x="841247" y="3319272"/>
-            <a:ext cx="3044952" cy="576072"/>
-          </a:xfrm>
-          <a:prstGeom prst="rect">
-            <a:avLst/>
-          </a:prstGeom>
-          <a:noFill/>
-        </p:spPr>
-        <p:txBody>
-          <a:bodyPr wrap="square">
-            <a:spAutoFit/>
-          </a:bodyPr>
-          <a:lstStyle/>
-          <a:p>
-            <a:r>
-              <a:rPr sz="1500">
-                <a:solidFill>
-                  <a:srgbClr val="E2EAF4"/>
-                </a:solidFill>
-                <a:latin typeface="Aptos"/>
-              </a:rPr>
-              <a:t>Resolve n−1 discos usando o pino auxiliar.</a:t>
-            </a:r>
-          </a:p>
-        </p:txBody>
-      </p:sp>
-      <p:sp>
-        <p:nvSpPr>
-          <p:cNvPr id="13" name="Rounded Rectangle 12"/>
-          <p:cNvSpPr/>
-          <p:nvPr/>
-        </p:nvSpPr>
-        <p:spPr>
-          <a:xfrm>
-            <a:off x="640080" y="4251960"/>
-            <a:ext cx="3429000" cy="1325880"/>
-          </a:xfrm>
-          <a:prstGeom prst="roundRect">
-            <a:avLst/>
-          </a:prstGeom>
-          <a:solidFill>
-            <a:srgbClr val="102A4E"/>
-          </a:solidFill>
-          <a:ln w="12700">
-            <a:solidFill>
-              <a:srgbClr val="274C78"/>
-            </a:solidFill>
-          </a:ln>
-        </p:spPr>
-        <p:style>
-          <a:lnRef idx="1">
-            <a:schemeClr val="accent1"/>
-          </a:lnRef>
-          <a:fillRef idx="3">
-            <a:schemeClr val="accent1"/>
-          </a:fillRef>
-          <a:effectRef idx="2">
-            <a:schemeClr val="accent1"/>
-          </a:effectRef>
-          <a:fontRef idx="minor">
-            <a:schemeClr val="lt1"/>
-          </a:fontRef>
-        </p:style>
-        <p:txBody>
-          <a:bodyPr rtlCol="0" anchor="ctr"/>
-          <a:lstStyle/>
-          <a:p>
-            <a:pPr algn="ctr"/>
-            <a:endParaRPr/>
-          </a:p>
-        </p:txBody>
-      </p:sp>
-      <p:sp>
-        <p:nvSpPr>
-          <p:cNvPr id="14" name="Rectangle 13"/>
-          <p:cNvSpPr/>
-          <p:nvPr/>
-        </p:nvSpPr>
-        <p:spPr>
-          <a:xfrm>
-            <a:off x="640080" y="4251960"/>
-            <a:ext cx="64008" cy="1325880"/>
-          </a:xfrm>
-          <a:prstGeom prst="rect">
-            <a:avLst/>
-          </a:prstGeom>
-          <a:solidFill>
-            <a:srgbClr val="FF8930"/>
-          </a:solidFill>
-          <a:ln>
-            <a:noFill/>
-          </a:ln>
-        </p:spPr>
-        <p:style>
-          <a:lnRef idx="1">
-            <a:schemeClr val="accent1"/>
-          </a:lnRef>
-          <a:fillRef idx="3">
-            <a:schemeClr val="accent1"/>
-          </a:fillRef>
-          <a:effectRef idx="2">
-            <a:schemeClr val="accent1"/>
-          </a:effectRef>
-          <a:fontRef idx="minor">
-            <a:schemeClr val="lt1"/>
-          </a:fontRef>
-        </p:style>
-        <p:txBody>
-          <a:bodyPr rtlCol="0" anchor="ctr"/>
-          <a:lstStyle/>
-          <a:p>
-            <a:pPr algn="ctr"/>
-            <a:endParaRPr/>
-          </a:p>
-        </p:txBody>
-      </p:sp>
-      <p:sp>
-        <p:nvSpPr>
-          <p:cNvPr id="15" name="TextBox 14"/>
-          <p:cNvSpPr txBox="1"/>
-          <p:nvPr/>
-        </p:nvSpPr>
-        <p:spPr>
-          <a:xfrm>
-            <a:off x="841247" y="4416552"/>
-            <a:ext cx="3044952" cy="365760"/>
-          </a:xfrm>
-          <a:prstGeom prst="rect">
-            <a:avLst/>
-          </a:prstGeom>
-          <a:noFill/>
-        </p:spPr>
-        <p:txBody>
-          <a:bodyPr wrap="none">
-            <a:spAutoFit/>
-          </a:bodyPr>
-          <a:lstStyle/>
-          <a:p>
-            <a:r>
-              <a:rPr sz="1700" b="1">
-                <a:solidFill>
-                  <a:srgbClr val="F8FAFC"/>
-                </a:solidFill>
-                <a:latin typeface="Aptos"/>
-              </a:rPr>
-              <a:t>3. Movimento final</a:t>
-            </a:r>
-          </a:p>
-        </p:txBody>
-      </p:sp>
-      <p:sp>
-        <p:nvSpPr>
-          <p:cNvPr id="16" name="TextBox 15"/>
-          <p:cNvSpPr txBox="1"/>
-          <p:nvPr/>
-        </p:nvSpPr>
-        <p:spPr>
-          <a:xfrm>
-            <a:off x="841247" y="4873752"/>
-            <a:ext cx="3044952" cy="576072"/>
-          </a:xfrm>
-          <a:prstGeom prst="rect">
-            <a:avLst/>
-          </a:prstGeom>
-          <a:noFill/>
-        </p:spPr>
-        <p:txBody>
-          <a:bodyPr wrap="square">
-            <a:spAutoFit/>
-          </a:bodyPr>
-          <a:lstStyle/>
-          <a:p>
-            <a:r>
-              <a:rPr sz="1500">
-                <a:solidFill>
-                  <a:srgbClr val="E2EAF4"/>
-                </a:solidFill>
-                <a:latin typeface="Aptos"/>
-              </a:rPr>
-              <a:t>Move o maior disco e resolve novamente n−1.</a:t>
-            </a:r>
-          </a:p>
-        </p:txBody>
-      </p:sp>
-      <p:sp>
-        <p:nvSpPr>
           <p:cNvPr id="17" name="Rounded Rectangle 16"/>
           <p:cNvSpPr/>
           <p:nvPr/>
         </p:nvSpPr>
         <p:spPr>
           <a:xfrm>
-            <a:off x="4434840" y="1325880"/>
-            <a:ext cx="7086600" cy="4251960"/>
+            <a:off x="640080" y="1323868"/>
+            <a:ext cx="10652760" cy="4251960"/>
           </a:xfrm>
           <a:prstGeom prst="roundRect">
             <a:avLst/>
@@ -7942,8 +7460,8 @@
         </p:nvSpPr>
         <p:spPr>
           <a:xfrm>
-            <a:off x="4636007" y="1490472"/>
-            <a:ext cx="6532558" cy="2246769"/>
+            <a:off x="1333249" y="1325880"/>
+            <a:ext cx="6643165" cy="4247317"/>
           </a:xfrm>
           <a:prstGeom prst="rect">
             <a:avLst/>
@@ -7957,324 +7475,172 @@
           <a:lstStyle/>
           <a:p>
             <a:r>
-              <a:rPr sz="2000" dirty="0" err="1" smtClean="0">
+              <a:rPr lang="pt-BR" dirty="0">
                 <a:solidFill>
                   <a:srgbClr val="DAE7F6"/>
                 </a:solidFill>
                 <a:latin typeface="Consolas"/>
               </a:rPr>
-              <a:t>hanoi</a:t>
-            </a:r>
-            <a:r>
-              <a:rPr sz="2000" dirty="0" smtClean="0">
+              <a:t>function hanoi(</a:t>
+            </a:r>
+          </a:p>
+          <a:p>
+            <a:r>
+              <a:rPr lang="pt-BR" dirty="0">
                 <a:solidFill>
                   <a:srgbClr val="DAE7F6"/>
                 </a:solidFill>
                 <a:latin typeface="Consolas"/>
               </a:rPr>
-              <a:t>(n, </a:t>
-            </a:r>
-            <a:r>
-              <a:rPr sz="2000" dirty="0" err="1" smtClean="0">
+              <a:t>  n: number,</a:t>
+            </a:r>
+          </a:p>
+          <a:p>
+            <a:r>
+              <a:rPr lang="pt-BR" dirty="0">
                 <a:solidFill>
                   <a:srgbClr val="DAE7F6"/>
                 </a:solidFill>
                 <a:latin typeface="Consolas"/>
               </a:rPr>
-              <a:t>origem</a:t>
-            </a:r>
-            <a:r>
-              <a:rPr sz="2000" dirty="0" smtClean="0">
+              <a:t>  origem: Pino,</a:t>
+            </a:r>
+          </a:p>
+          <a:p>
+            <a:r>
+              <a:rPr lang="pt-BR" dirty="0">
                 <a:solidFill>
                   <a:srgbClr val="DAE7F6"/>
                 </a:solidFill>
                 <a:latin typeface="Consolas"/>
               </a:rPr>
-              <a:t>, </a:t>
-            </a:r>
-            <a:r>
-              <a:rPr sz="2000" dirty="0" err="1" smtClean="0">
+              <a:t>  auxiliar: Pino,</a:t>
+            </a:r>
+          </a:p>
+          <a:p>
+            <a:r>
+              <a:rPr lang="pt-BR" dirty="0">
                 <a:solidFill>
                   <a:srgbClr val="DAE7F6"/>
                 </a:solidFill>
                 <a:latin typeface="Consolas"/>
               </a:rPr>
-              <a:t>destino</a:t>
-            </a:r>
-            <a:r>
-              <a:rPr sz="2000" dirty="0" smtClean="0">
+              <a:t>  destino: Pino</a:t>
+            </a:r>
+          </a:p>
+          <a:p>
+            <a:r>
+              <a:rPr lang="pt-BR" dirty="0">
                 <a:solidFill>
                   <a:srgbClr val="DAE7F6"/>
                 </a:solidFill>
                 <a:latin typeface="Consolas"/>
               </a:rPr>
-              <a:t>, </a:t>
-            </a:r>
-            <a:r>
-              <a:rPr sz="2000" dirty="0" err="1" smtClean="0">
+              <a:t>): void {</a:t>
+            </a:r>
+          </a:p>
+          <a:p>
+            <a:r>
+              <a:rPr lang="pt-BR" dirty="0">
                 <a:solidFill>
                   <a:srgbClr val="DAE7F6"/>
                 </a:solidFill>
                 <a:latin typeface="Consolas"/>
               </a:rPr>
-              <a:t>auxiliar</a:t>
-            </a:r>
-            <a:r>
-              <a:rPr sz="2000" dirty="0" smtClean="0">
+              <a:t>  if (n === 1) {</a:t>
+            </a:r>
+          </a:p>
+          <a:p>
+            <a:r>
+              <a:rPr lang="pt-BR" dirty="0">
                 <a:solidFill>
                   <a:srgbClr val="DAE7F6"/>
                 </a:solidFill>
                 <a:latin typeface="Consolas"/>
               </a:rPr>
-              <a:t>):
-    se n == 1:
-        mover(</a:t>
-            </a:r>
-            <a:r>
-              <a:rPr sz="2000" dirty="0" err="1" smtClean="0">
+              <a:t>    movimentos.push({ disco: 1, origem, destino });</a:t>
+            </a:r>
+          </a:p>
+          <a:p>
+            <a:r>
+              <a:rPr lang="pt-BR" dirty="0">
                 <a:solidFill>
                   <a:srgbClr val="DAE7F6"/>
                 </a:solidFill>
                 <a:latin typeface="Consolas"/>
               </a:rPr>
-              <a:t>origem</a:t>
-            </a:r>
-            <a:r>
-              <a:rPr sz="2000" dirty="0" smtClean="0">
+              <a:t>    return;</a:t>
+            </a:r>
+          </a:p>
+          <a:p>
+            <a:r>
+              <a:rPr lang="pt-BR" dirty="0">
                 <a:solidFill>
                   <a:srgbClr val="DAE7F6"/>
                 </a:solidFill>
                 <a:latin typeface="Consolas"/>
               </a:rPr>
-              <a:t>, </a:t>
-            </a:r>
-            <a:r>
-              <a:rPr sz="2000" dirty="0" err="1" smtClean="0">
-                <a:solidFill>
-                  <a:srgbClr val="DAE7F6"/>
-                </a:solidFill>
-                <a:latin typeface="Consolas"/>
-              </a:rPr>
-              <a:t>destino</a:t>
-            </a:r>
-            <a:r>
-              <a:rPr sz="2000" dirty="0" smtClean="0">
-                <a:solidFill>
-                  <a:srgbClr val="DAE7F6"/>
-                </a:solidFill>
-                <a:latin typeface="Consolas"/>
-              </a:rPr>
-              <a:t>)
-    </a:t>
-            </a:r>
-            <a:r>
-              <a:rPr sz="2000" dirty="0" err="1" smtClean="0">
-                <a:solidFill>
-                  <a:srgbClr val="DAE7F6"/>
-                </a:solidFill>
-                <a:latin typeface="Consolas"/>
-              </a:rPr>
-              <a:t>senão</a:t>
-            </a:r>
-            <a:r>
-              <a:rPr sz="2000" dirty="0" smtClean="0">
-                <a:solidFill>
-                  <a:srgbClr val="DAE7F6"/>
-                </a:solidFill>
-                <a:latin typeface="Consolas"/>
-              </a:rPr>
-              <a:t>:
-        </a:t>
-            </a:r>
-            <a:r>
-              <a:rPr sz="2000" dirty="0" err="1" smtClean="0">
-                <a:solidFill>
-                  <a:srgbClr val="DAE7F6"/>
-                </a:solidFill>
-                <a:latin typeface="Consolas"/>
-              </a:rPr>
-              <a:t>hanoi</a:t>
-            </a:r>
-            <a:r>
-              <a:rPr sz="2000" dirty="0" smtClean="0">
-                <a:solidFill>
-                  <a:srgbClr val="DAE7F6"/>
-                </a:solidFill>
-                <a:latin typeface="Consolas"/>
-              </a:rPr>
-              <a:t>(n-1, </a:t>
-            </a:r>
-            <a:r>
-              <a:rPr sz="2000" dirty="0" err="1" smtClean="0">
-                <a:solidFill>
-                  <a:srgbClr val="DAE7F6"/>
-                </a:solidFill>
-                <a:latin typeface="Consolas"/>
-              </a:rPr>
-              <a:t>origem</a:t>
-            </a:r>
-            <a:r>
-              <a:rPr sz="2000" dirty="0" smtClean="0">
-                <a:solidFill>
-                  <a:srgbClr val="DAE7F6"/>
-                </a:solidFill>
-                <a:latin typeface="Consolas"/>
-              </a:rPr>
-              <a:t>, </a:t>
-            </a:r>
-            <a:r>
-              <a:rPr sz="2000" dirty="0" err="1" smtClean="0">
-                <a:solidFill>
-                  <a:srgbClr val="DAE7F6"/>
-                </a:solidFill>
-                <a:latin typeface="Consolas"/>
-              </a:rPr>
-              <a:t>auxiliar</a:t>
-            </a:r>
-            <a:r>
-              <a:rPr sz="2000" dirty="0" smtClean="0">
-                <a:solidFill>
-                  <a:srgbClr val="DAE7F6"/>
-                </a:solidFill>
-                <a:latin typeface="Consolas"/>
-              </a:rPr>
-              <a:t>, </a:t>
-            </a:r>
-            <a:r>
-              <a:rPr sz="2000" dirty="0" err="1" smtClean="0">
-                <a:solidFill>
-                  <a:srgbClr val="DAE7F6"/>
-                </a:solidFill>
-                <a:latin typeface="Consolas"/>
-              </a:rPr>
-              <a:t>destino</a:t>
-            </a:r>
-            <a:r>
-              <a:rPr sz="2000" dirty="0" smtClean="0">
-                <a:solidFill>
-                  <a:srgbClr val="DAE7F6"/>
-                </a:solidFill>
-                <a:latin typeface="Consolas"/>
-              </a:rPr>
-              <a:t>)
-        mover(</a:t>
-            </a:r>
-            <a:r>
-              <a:rPr sz="2000" dirty="0" err="1" smtClean="0">
-                <a:solidFill>
-                  <a:srgbClr val="DAE7F6"/>
-                </a:solidFill>
-                <a:latin typeface="Consolas"/>
-              </a:rPr>
-              <a:t>origem</a:t>
-            </a:r>
-            <a:r>
-              <a:rPr sz="2000" dirty="0" smtClean="0">
-                <a:solidFill>
-                  <a:srgbClr val="DAE7F6"/>
-                </a:solidFill>
-                <a:latin typeface="Consolas"/>
-              </a:rPr>
-              <a:t>, </a:t>
-            </a:r>
-            <a:r>
-              <a:rPr sz="2000" dirty="0" err="1" smtClean="0">
-                <a:solidFill>
-                  <a:srgbClr val="DAE7F6"/>
-                </a:solidFill>
-                <a:latin typeface="Consolas"/>
-              </a:rPr>
-              <a:t>destino</a:t>
-            </a:r>
-            <a:r>
-              <a:rPr sz="2000" dirty="0" smtClean="0">
-                <a:solidFill>
-                  <a:srgbClr val="DAE7F6"/>
-                </a:solidFill>
-                <a:latin typeface="Consolas"/>
-              </a:rPr>
-              <a:t>)
-        </a:t>
-            </a:r>
-            <a:r>
-              <a:rPr sz="2000" dirty="0" err="1" smtClean="0">
-                <a:solidFill>
-                  <a:srgbClr val="DAE7F6"/>
-                </a:solidFill>
-                <a:latin typeface="Consolas"/>
-              </a:rPr>
-              <a:t>hanoi</a:t>
-            </a:r>
-            <a:r>
-              <a:rPr sz="2000" dirty="0" smtClean="0">
-                <a:solidFill>
-                  <a:srgbClr val="DAE7F6"/>
-                </a:solidFill>
-                <a:latin typeface="Consolas"/>
-              </a:rPr>
-              <a:t>(n-1, </a:t>
-            </a:r>
-            <a:r>
-              <a:rPr sz="2000" dirty="0" err="1" smtClean="0">
-                <a:solidFill>
-                  <a:srgbClr val="DAE7F6"/>
-                </a:solidFill>
-                <a:latin typeface="Consolas"/>
-              </a:rPr>
-              <a:t>auxiliar</a:t>
-            </a:r>
-            <a:r>
-              <a:rPr sz="2000" dirty="0" smtClean="0">
-                <a:solidFill>
-                  <a:srgbClr val="DAE7F6"/>
-                </a:solidFill>
-                <a:latin typeface="Consolas"/>
-              </a:rPr>
-              <a:t>, </a:t>
-            </a:r>
-            <a:r>
-              <a:rPr sz="2000" dirty="0" err="1" smtClean="0">
-                <a:solidFill>
-                  <a:srgbClr val="DAE7F6"/>
-                </a:solidFill>
-                <a:latin typeface="Consolas"/>
-              </a:rPr>
-              <a:t>destino</a:t>
-            </a:r>
-            <a:r>
-              <a:rPr sz="2000" dirty="0" smtClean="0">
-                <a:solidFill>
-                  <a:srgbClr val="DAE7F6"/>
-                </a:solidFill>
-                <a:latin typeface="Consolas"/>
-              </a:rPr>
-              <a:t>, </a:t>
-            </a:r>
-            <a:r>
-              <a:rPr sz="2000" dirty="0" err="1" smtClean="0">
-                <a:solidFill>
-                  <a:srgbClr val="DAE7F6"/>
-                </a:solidFill>
-                <a:latin typeface="Consolas"/>
-              </a:rPr>
-              <a:t>origem</a:t>
-            </a:r>
-            <a:r>
-              <a:rPr sz="2000" dirty="0" smtClean="0">
-                <a:solidFill>
-                  <a:srgbClr val="DAE7F6"/>
-                </a:solidFill>
-                <a:latin typeface="Consolas"/>
-              </a:rPr>
-              <a:t>)</a:t>
-            </a:r>
-            <a:endParaRPr sz="2000" dirty="0">
+              <a:t>  }</a:t>
+            </a:r>
+          </a:p>
+          <a:p>
+            <a:endParaRPr lang="pt-BR" dirty="0">
               <a:solidFill>
                 <a:srgbClr val="DAE7F6"/>
               </a:solidFill>
               <a:latin typeface="Consolas"/>
             </a:endParaRPr>
           </a:p>
+          <a:p>
+            <a:r>
+              <a:rPr lang="pt-BR" dirty="0">
+                <a:solidFill>
+                  <a:srgbClr val="DAE7F6"/>
+                </a:solidFill>
+                <a:latin typeface="Consolas"/>
+              </a:rPr>
+              <a:t>  hanoi(n - 1, origem, destino, auxiliar);</a:t>
+            </a:r>
+          </a:p>
+          <a:p>
+            <a:r>
+              <a:rPr lang="pt-BR" dirty="0">
+                <a:solidFill>
+                  <a:srgbClr val="DAE7F6"/>
+                </a:solidFill>
+                <a:latin typeface="Consolas"/>
+              </a:rPr>
+              <a:t>  movimentos.push({ disco: n, origem, destino });</a:t>
+            </a:r>
+          </a:p>
+          <a:p>
+            <a:r>
+              <a:rPr lang="pt-BR" dirty="0">
+                <a:solidFill>
+                  <a:srgbClr val="DAE7F6"/>
+                </a:solidFill>
+                <a:latin typeface="Consolas"/>
+              </a:rPr>
+              <a:t>  hanoi(n - 1, auxiliar, origem, destino);</a:t>
+            </a:r>
+          </a:p>
+          <a:p>
+            <a:r>
+              <a:rPr lang="pt-BR" dirty="0">
+                <a:solidFill>
+                  <a:srgbClr val="DAE7F6"/>
+                </a:solidFill>
+                <a:latin typeface="Consolas"/>
+              </a:rPr>
+              <a:t>}</a:t>
+            </a:r>
+            <a:endParaRPr dirty="0">
+              <a:solidFill>
+                <a:srgbClr val="DAE7F6"/>
+              </a:solidFill>
+              <a:latin typeface="Consolas"/>
+            </a:endParaRPr>
+          </a:p>
         </p:txBody>
       </p:sp>
       <p:sp>
@@ -8341,25 +7707,7 @@
                 </a:solidFill>
                 <a:latin typeface="Aptos"/>
               </a:rPr>
-              <a:t>FATEC • Torre de </a:t>
-            </a:r>
-            <a:r>
-              <a:rPr sz="900" dirty="0" err="1">
-                <a:solidFill>
-                  <a:srgbClr val="A0B4CD"/>
-                </a:solidFill>
-                <a:latin typeface="Aptos"/>
-              </a:rPr>
-              <a:t>Hanói</a:t>
-            </a:r>
-            <a:r>
-              <a:rPr sz="900" dirty="0">
-                <a:solidFill>
-                  <a:srgbClr val="A0B4CD"/>
-                </a:solidFill>
-                <a:latin typeface="Aptos"/>
-              </a:rPr>
-              <a:t>   |   </a:t>
+              <a:t>FATEC • Torre de Hanói   |   </a:t>
             </a:r>
             <a:r>
               <a:rPr lang="pt-BR" sz="900" dirty="0">
@@ -9107,7 +8455,6 @@
               <a:rPr lang="pt-BR" sz="1400" dirty="0"/>
               <a:t>Vinicius Augusto • Henrique Camargo</a:t>
             </a:r>
-            <a:endParaRPr lang="pt-BR" sz="1400" dirty="0"/>
           </a:p>
         </p:txBody>
       </p:sp>

</xml_diff>

<commit_message>
docs: atualização da apresentação final do projeto
</commit_message>
<xml_diff>
--- a/docs/Torre_de_Hanoi_FATEC_Apresentacao.pptx
+++ b/docs/Torre_de_Hanoi_FATEC_Apresentacao.pptx
@@ -10,8 +10,7 @@
     <p:sldId id="257" r:id="rId4"/>
     <p:sldId id="258" r:id="rId5"/>
     <p:sldId id="259" r:id="rId6"/>
-    <p:sldId id="262" r:id="rId7"/>
-    <p:sldId id="261" r:id="rId8"/>
+    <p:sldId id="261" r:id="rId7"/>
   </p:sldIdLst>
   <p:sldSz cx="12192000" cy="6858000"/>
   <p:notesSz cx="6858000" cy="9144000"/>
@@ -310,7 +309,7 @@
           <a:p>
             <a:fld id="{5BCAD085-E8A6-8845-BD4E-CB4CCA059FC4}" type="datetimeFigureOut">
               <a:rPr lang="en-US" smtClean="0"/>
-              <a:t>9/28/2026</a:t>
+              <a:t>9/29/2026</a:t>
             </a:fld>
             <a:endParaRPr lang="en-US"/>
           </a:p>
@@ -480,7 +479,7 @@
           <a:p>
             <a:fld id="{5BCAD085-E8A6-8845-BD4E-CB4CCA059FC4}" type="datetimeFigureOut">
               <a:rPr lang="en-US" smtClean="0"/>
-              <a:t>9/28/2026</a:t>
+              <a:t>9/29/2026</a:t>
             </a:fld>
             <a:endParaRPr lang="en-US"/>
           </a:p>
@@ -660,7 +659,7 @@
           <a:p>
             <a:fld id="{5BCAD085-E8A6-8845-BD4E-CB4CCA059FC4}" type="datetimeFigureOut">
               <a:rPr lang="en-US" smtClean="0"/>
-              <a:t>9/28/2026</a:t>
+              <a:t>9/29/2026</a:t>
             </a:fld>
             <a:endParaRPr lang="en-US"/>
           </a:p>
@@ -830,7 +829,7 @@
           <a:p>
             <a:fld id="{5BCAD085-E8A6-8845-BD4E-CB4CCA059FC4}" type="datetimeFigureOut">
               <a:rPr lang="en-US" smtClean="0"/>
-              <a:t>9/28/2026</a:t>
+              <a:t>9/29/2026</a:t>
             </a:fld>
             <a:endParaRPr lang="en-US"/>
           </a:p>
@@ -1076,7 +1075,7 @@
           <a:p>
             <a:fld id="{5BCAD085-E8A6-8845-BD4E-CB4CCA059FC4}" type="datetimeFigureOut">
               <a:rPr lang="en-US" smtClean="0"/>
-              <a:t>9/28/2026</a:t>
+              <a:t>9/29/2026</a:t>
             </a:fld>
             <a:endParaRPr lang="en-US"/>
           </a:p>
@@ -1364,7 +1363,7 @@
           <a:p>
             <a:fld id="{5BCAD085-E8A6-8845-BD4E-CB4CCA059FC4}" type="datetimeFigureOut">
               <a:rPr lang="en-US" smtClean="0"/>
-              <a:t>9/28/2026</a:t>
+              <a:t>9/29/2026</a:t>
             </a:fld>
             <a:endParaRPr lang="en-US"/>
           </a:p>
@@ -1786,7 +1785,7 @@
           <a:p>
             <a:fld id="{5BCAD085-E8A6-8845-BD4E-CB4CCA059FC4}" type="datetimeFigureOut">
               <a:rPr lang="en-US" smtClean="0"/>
-              <a:t>9/28/2026</a:t>
+              <a:t>9/29/2026</a:t>
             </a:fld>
             <a:endParaRPr lang="en-US"/>
           </a:p>
@@ -1904,7 +1903,7 @@
           <a:p>
             <a:fld id="{5BCAD085-E8A6-8845-BD4E-CB4CCA059FC4}" type="datetimeFigureOut">
               <a:rPr lang="en-US" smtClean="0"/>
-              <a:t>9/28/2026</a:t>
+              <a:t>9/29/2026</a:t>
             </a:fld>
             <a:endParaRPr lang="en-US"/>
           </a:p>
@@ -1999,7 +1998,7 @@
           <a:p>
             <a:fld id="{5BCAD085-E8A6-8845-BD4E-CB4CCA059FC4}" type="datetimeFigureOut">
               <a:rPr lang="en-US" smtClean="0"/>
-              <a:t>9/28/2026</a:t>
+              <a:t>9/29/2026</a:t>
             </a:fld>
             <a:endParaRPr lang="en-US"/>
           </a:p>
@@ -2276,7 +2275,7 @@
           <a:p>
             <a:fld id="{5BCAD085-E8A6-8845-BD4E-CB4CCA059FC4}" type="datetimeFigureOut">
               <a:rPr lang="en-US" smtClean="0"/>
-              <a:t>9/28/2026</a:t>
+              <a:t>9/29/2026</a:t>
             </a:fld>
             <a:endParaRPr lang="en-US"/>
           </a:p>
@@ -2529,7 +2528,7 @@
           <a:p>
             <a:fld id="{5BCAD085-E8A6-8845-BD4E-CB4CCA059FC4}" type="datetimeFigureOut">
               <a:rPr lang="en-US" smtClean="0"/>
-              <a:t>9/28/2026</a:t>
+              <a:t>9/29/2026</a:t>
             </a:fld>
             <a:endParaRPr lang="en-US"/>
           </a:p>
@@ -2742,7 +2741,7 @@
           <a:p>
             <a:fld id="{5BCAD085-E8A6-8845-BD4E-CB4CCA059FC4}" type="datetimeFigureOut">
               <a:rPr lang="en-US" smtClean="0"/>
-              <a:t>9/28/2026</a:t>
+              <a:t>9/29/2026</a:t>
             </a:fld>
             <a:endParaRPr lang="en-US"/>
           </a:p>
@@ -7317,7 +7316,7 @@
         <p:spPr>
           <a:xfrm>
             <a:off x="640080" y="347472"/>
-            <a:ext cx="5750870" cy="523220"/>
+            <a:ext cx="3001143" cy="523220"/>
           </a:xfrm>
           <a:prstGeom prst="rect">
             <a:avLst/>
@@ -7338,514 +7337,6 @@
                 <a:latin typeface="Aptos Display"/>
               </a:rPr>
               <a:t>5</a:t>
-            </a:r>
-            <a:r>
-              <a:rPr sz="2800" b="1" dirty="0" smtClean="0">
-                <a:solidFill>
-                  <a:srgbClr val="F8FAFC"/>
-                </a:solidFill>
-                <a:latin typeface="Aptos Display"/>
-              </a:rPr>
-              <a:t>. </a:t>
-            </a:r>
-            <a:r>
-              <a:rPr lang="pt-BR" sz="2800" b="1" dirty="0">
-                <a:solidFill>
-                  <a:srgbClr val="F8FAFC"/>
-                </a:solidFill>
-                <a:latin typeface="Aptos Display"/>
-              </a:rPr>
-              <a:t>Implementação em TypeScript</a:t>
-            </a:r>
-            <a:endParaRPr sz="2800" b="1" dirty="0">
-              <a:solidFill>
-                <a:srgbClr val="F8FAFC"/>
-              </a:solidFill>
-              <a:latin typeface="Aptos Display"/>
-            </a:endParaRPr>
-          </a:p>
-        </p:txBody>
-      </p:sp>
-      <p:sp>
-        <p:nvSpPr>
-          <p:cNvPr id="4" name="TextBox 3"/>
-          <p:cNvSpPr txBox="1"/>
-          <p:nvPr/>
-        </p:nvSpPr>
-        <p:spPr>
-          <a:xfrm>
-            <a:off x="658368" y="914400"/>
-            <a:ext cx="2746714" cy="292388"/>
-          </a:xfrm>
-          <a:prstGeom prst="rect">
-            <a:avLst/>
-          </a:prstGeom>
-          <a:noFill/>
-        </p:spPr>
-        <p:txBody>
-          <a:bodyPr wrap="none">
-            <a:spAutoFit/>
-          </a:bodyPr>
-          <a:lstStyle/>
-          <a:p>
-            <a:r>
-              <a:rPr lang="pt-BR" sz="1300" dirty="0" smtClean="0">
-                <a:solidFill>
-                  <a:srgbClr val="A0B4CD"/>
-                </a:solidFill>
-                <a:latin typeface="Aptos"/>
-              </a:rPr>
-              <a:t>Código usado na nossa Aplicação.</a:t>
-            </a:r>
-            <a:endParaRPr sz="1300" dirty="0">
-              <a:solidFill>
-                <a:srgbClr val="A0B4CD"/>
-              </a:solidFill>
-              <a:latin typeface="Aptos"/>
-            </a:endParaRPr>
-          </a:p>
-        </p:txBody>
-      </p:sp>
-      <p:sp>
-        <p:nvSpPr>
-          <p:cNvPr id="17" name="Rounded Rectangle 16"/>
-          <p:cNvSpPr/>
-          <p:nvPr/>
-        </p:nvSpPr>
-        <p:spPr>
-          <a:xfrm>
-            <a:off x="640080" y="1323868"/>
-            <a:ext cx="10652760" cy="4251960"/>
-          </a:xfrm>
-          <a:prstGeom prst="roundRect">
-            <a:avLst/>
-          </a:prstGeom>
-          <a:solidFill>
-            <a:srgbClr val="051123"/>
-          </a:solidFill>
-          <a:ln>
-            <a:solidFill>
-              <a:srgbClr val="28496F"/>
-            </a:solidFill>
-          </a:ln>
-        </p:spPr>
-        <p:style>
-          <a:lnRef idx="1">
-            <a:schemeClr val="accent1"/>
-          </a:lnRef>
-          <a:fillRef idx="3">
-            <a:schemeClr val="accent1"/>
-          </a:fillRef>
-          <a:effectRef idx="2">
-            <a:schemeClr val="accent1"/>
-          </a:effectRef>
-          <a:fontRef idx="minor">
-            <a:schemeClr val="lt1"/>
-          </a:fontRef>
-        </p:style>
-        <p:txBody>
-          <a:bodyPr rtlCol="0" anchor="ctr"/>
-          <a:lstStyle/>
-          <a:p>
-            <a:pPr algn="ctr"/>
-            <a:endParaRPr/>
-          </a:p>
-        </p:txBody>
-      </p:sp>
-      <p:sp>
-        <p:nvSpPr>
-          <p:cNvPr id="18" name="TextBox 17"/>
-          <p:cNvSpPr txBox="1"/>
-          <p:nvPr/>
-        </p:nvSpPr>
-        <p:spPr>
-          <a:xfrm>
-            <a:off x="1333249" y="1325880"/>
-            <a:ext cx="6643165" cy="4247317"/>
-          </a:xfrm>
-          <a:prstGeom prst="rect">
-            <a:avLst/>
-          </a:prstGeom>
-          <a:noFill/>
-        </p:spPr>
-        <p:txBody>
-          <a:bodyPr wrap="none">
-            <a:spAutoFit/>
-          </a:bodyPr>
-          <a:lstStyle/>
-          <a:p>
-            <a:r>
-              <a:rPr lang="pt-BR" dirty="0">
-                <a:solidFill>
-                  <a:srgbClr val="DAE7F6"/>
-                </a:solidFill>
-                <a:latin typeface="Consolas"/>
-              </a:rPr>
-              <a:t>function hanoi(</a:t>
-            </a:r>
-          </a:p>
-          <a:p>
-            <a:r>
-              <a:rPr lang="pt-BR" dirty="0">
-                <a:solidFill>
-                  <a:srgbClr val="DAE7F6"/>
-                </a:solidFill>
-                <a:latin typeface="Consolas"/>
-              </a:rPr>
-              <a:t>  n: number,</a:t>
-            </a:r>
-          </a:p>
-          <a:p>
-            <a:r>
-              <a:rPr lang="pt-BR" dirty="0">
-                <a:solidFill>
-                  <a:srgbClr val="DAE7F6"/>
-                </a:solidFill>
-                <a:latin typeface="Consolas"/>
-              </a:rPr>
-              <a:t>  origem: Pino,</a:t>
-            </a:r>
-          </a:p>
-          <a:p>
-            <a:r>
-              <a:rPr lang="pt-BR" dirty="0">
-                <a:solidFill>
-                  <a:srgbClr val="DAE7F6"/>
-                </a:solidFill>
-                <a:latin typeface="Consolas"/>
-              </a:rPr>
-              <a:t>  auxiliar: Pino,</a:t>
-            </a:r>
-          </a:p>
-          <a:p>
-            <a:r>
-              <a:rPr lang="pt-BR" dirty="0">
-                <a:solidFill>
-                  <a:srgbClr val="DAE7F6"/>
-                </a:solidFill>
-                <a:latin typeface="Consolas"/>
-              </a:rPr>
-              <a:t>  destino: Pino</a:t>
-            </a:r>
-          </a:p>
-          <a:p>
-            <a:r>
-              <a:rPr lang="pt-BR" dirty="0">
-                <a:solidFill>
-                  <a:srgbClr val="DAE7F6"/>
-                </a:solidFill>
-                <a:latin typeface="Consolas"/>
-              </a:rPr>
-              <a:t>): void {</a:t>
-            </a:r>
-          </a:p>
-          <a:p>
-            <a:r>
-              <a:rPr lang="pt-BR" dirty="0">
-                <a:solidFill>
-                  <a:srgbClr val="DAE7F6"/>
-                </a:solidFill>
-                <a:latin typeface="Consolas"/>
-              </a:rPr>
-              <a:t>  if (n === 1) {</a:t>
-            </a:r>
-          </a:p>
-          <a:p>
-            <a:r>
-              <a:rPr lang="pt-BR" dirty="0">
-                <a:solidFill>
-                  <a:srgbClr val="DAE7F6"/>
-                </a:solidFill>
-                <a:latin typeface="Consolas"/>
-              </a:rPr>
-              <a:t>    movimentos.push({ disco: 1, origem, destino });</a:t>
-            </a:r>
-          </a:p>
-          <a:p>
-            <a:r>
-              <a:rPr lang="pt-BR" dirty="0">
-                <a:solidFill>
-                  <a:srgbClr val="DAE7F6"/>
-                </a:solidFill>
-                <a:latin typeface="Consolas"/>
-              </a:rPr>
-              <a:t>    return;</a:t>
-            </a:r>
-          </a:p>
-          <a:p>
-            <a:r>
-              <a:rPr lang="pt-BR" dirty="0">
-                <a:solidFill>
-                  <a:srgbClr val="DAE7F6"/>
-                </a:solidFill>
-                <a:latin typeface="Consolas"/>
-              </a:rPr>
-              <a:t>  }</a:t>
-            </a:r>
-          </a:p>
-          <a:p>
-            <a:endParaRPr lang="pt-BR" dirty="0">
-              <a:solidFill>
-                <a:srgbClr val="DAE7F6"/>
-              </a:solidFill>
-              <a:latin typeface="Consolas"/>
-            </a:endParaRPr>
-          </a:p>
-          <a:p>
-            <a:r>
-              <a:rPr lang="pt-BR" dirty="0">
-                <a:solidFill>
-                  <a:srgbClr val="DAE7F6"/>
-                </a:solidFill>
-                <a:latin typeface="Consolas"/>
-              </a:rPr>
-              <a:t>  hanoi(n - 1, origem, destino, auxiliar);</a:t>
-            </a:r>
-          </a:p>
-          <a:p>
-            <a:r>
-              <a:rPr lang="pt-BR" dirty="0">
-                <a:solidFill>
-                  <a:srgbClr val="DAE7F6"/>
-                </a:solidFill>
-                <a:latin typeface="Consolas"/>
-              </a:rPr>
-              <a:t>  movimentos.push({ disco: n, origem, destino });</a:t>
-            </a:r>
-          </a:p>
-          <a:p>
-            <a:r>
-              <a:rPr lang="pt-BR" dirty="0">
-                <a:solidFill>
-                  <a:srgbClr val="DAE7F6"/>
-                </a:solidFill>
-                <a:latin typeface="Consolas"/>
-              </a:rPr>
-              <a:t>  hanoi(n - 1, auxiliar, origem, destino);</a:t>
-            </a:r>
-          </a:p>
-          <a:p>
-            <a:r>
-              <a:rPr lang="pt-BR" dirty="0">
-                <a:solidFill>
-                  <a:srgbClr val="DAE7F6"/>
-                </a:solidFill>
-                <a:latin typeface="Consolas"/>
-              </a:rPr>
-              <a:t>}</a:t>
-            </a:r>
-            <a:endParaRPr dirty="0">
-              <a:solidFill>
-                <a:srgbClr val="DAE7F6"/>
-              </a:solidFill>
-              <a:latin typeface="Consolas"/>
-            </a:endParaRPr>
-          </a:p>
-        </p:txBody>
-      </p:sp>
-      <p:sp>
-        <p:nvSpPr>
-          <p:cNvPr id="19" name="TextBox 18"/>
-          <p:cNvSpPr txBox="1"/>
-          <p:nvPr/>
-        </p:nvSpPr>
-        <p:spPr>
-          <a:xfrm>
-            <a:off x="4617720" y="5715000"/>
-            <a:ext cx="6675120" cy="457200"/>
-          </a:xfrm>
-          <a:prstGeom prst="rect">
-            <a:avLst/>
-          </a:prstGeom>
-          <a:noFill/>
-        </p:spPr>
-        <p:txBody>
-          <a:bodyPr wrap="none">
-            <a:spAutoFit/>
-          </a:bodyPr>
-          <a:lstStyle/>
-          <a:p>
-            <a:r>
-              <a:rPr sz="1500" b="1">
-                <a:solidFill>
-                  <a:srgbClr val="CDE1FF"/>
-                </a:solidFill>
-                <a:latin typeface="Aptos"/>
-              </a:rPr>
-              <a:t>Complexidade em movimentos: 2ⁿ − 1  •  Para 3 discos: 7 movimentos</a:t>
-            </a:r>
-          </a:p>
-        </p:txBody>
-      </p:sp>
-      <p:sp>
-        <p:nvSpPr>
-          <p:cNvPr id="20" name="TextBox 19"/>
-          <p:cNvSpPr txBox="1"/>
-          <p:nvPr/>
-        </p:nvSpPr>
-        <p:spPr>
-          <a:xfrm>
-            <a:off x="9889331" y="6473952"/>
-            <a:ext cx="1723549" cy="230832"/>
-          </a:xfrm>
-          <a:prstGeom prst="rect">
-            <a:avLst/>
-          </a:prstGeom>
-          <a:noFill/>
-        </p:spPr>
-        <p:txBody>
-          <a:bodyPr wrap="none">
-            <a:spAutoFit/>
-          </a:bodyPr>
-          <a:lstStyle/>
-          <a:p>
-            <a:pPr algn="r"/>
-            <a:r>
-              <a:rPr sz="900" dirty="0">
-                <a:solidFill>
-                  <a:srgbClr val="A0B4CD"/>
-                </a:solidFill>
-                <a:latin typeface="Aptos"/>
-              </a:rPr>
-              <a:t>FATEC • Torre de Hanói   |   </a:t>
-            </a:r>
-            <a:r>
-              <a:rPr lang="pt-BR" sz="900" dirty="0">
-                <a:solidFill>
-                  <a:srgbClr val="A0B4CD"/>
-                </a:solidFill>
-                <a:latin typeface="Aptos"/>
-              </a:rPr>
-              <a:t>6</a:t>
-            </a:r>
-            <a:endParaRPr lang="pt-BR" sz="900" dirty="0" smtClean="0">
-              <a:solidFill>
-                <a:srgbClr val="A0B4CD"/>
-              </a:solidFill>
-              <a:latin typeface="Aptos"/>
-            </a:endParaRPr>
-          </a:p>
-        </p:txBody>
-      </p:sp>
-    </p:spTree>
-    <p:extLst>
-      <p:ext uri="{BB962C8B-B14F-4D97-AF65-F5344CB8AC3E}">
-        <p14:creationId xmlns:p14="http://schemas.microsoft.com/office/powerpoint/2010/main" val="2230163047"/>
-      </p:ext>
-    </p:extLst>
-  </p:cSld>
-  <p:clrMapOvr>
-    <a:masterClrMapping/>
-  </p:clrMapOvr>
-  <p:timing>
-    <p:tnLst>
-      <p:par>
-        <p:cTn id="1" dur="indefinite" restart="never" nodeType="tmRoot"/>
-      </p:par>
-    </p:tnLst>
-  </p:timing>
-</p:sld>
-</file>
-
-<file path=ppt/slides/slide7.xml><?xml version="1.0" encoding="utf-8"?>
-<p:sld xmlns:a="http://schemas.openxmlformats.org/drawingml/2006/main" xmlns:r="http://schemas.openxmlformats.org/officeDocument/2006/relationships" xmlns:p="http://schemas.openxmlformats.org/presentationml/2006/main">
-  <p:cSld>
-    <p:bg>
-      <p:bgPr>
-        <a:solidFill>
-          <a:srgbClr val="091B36"/>
-        </a:solidFill>
-        <a:effectLst/>
-      </p:bgPr>
-    </p:bg>
-    <p:spTree>
-      <p:nvGrpSpPr>
-        <p:cNvPr id="1" name=""/>
-        <p:cNvGrpSpPr/>
-        <p:nvPr/>
-      </p:nvGrpSpPr>
-      <p:grpSpPr>
-        <a:xfrm>
-          <a:off x="0" y="0"/>
-          <a:ext cx="0" cy="0"/>
-          <a:chOff x="0" y="0"/>
-          <a:chExt cx="0" cy="0"/>
-        </a:xfrm>
-      </p:grpSpPr>
-      <p:sp>
-        <p:nvSpPr>
-          <p:cNvPr id="2" name="Rectangle 1"/>
-          <p:cNvSpPr/>
-          <p:nvPr/>
-        </p:nvSpPr>
-        <p:spPr>
-          <a:xfrm>
-            <a:off x="0" y="0"/>
-            <a:ext cx="12191695" cy="64008"/>
-          </a:xfrm>
-          <a:prstGeom prst="rect">
-            <a:avLst/>
-          </a:prstGeom>
-          <a:solidFill>
-            <a:srgbClr val="2D84FF"/>
-          </a:solidFill>
-          <a:ln>
-            <a:noFill/>
-          </a:ln>
-        </p:spPr>
-        <p:style>
-          <a:lnRef idx="1">
-            <a:schemeClr val="accent1"/>
-          </a:lnRef>
-          <a:fillRef idx="3">
-            <a:schemeClr val="accent1"/>
-          </a:fillRef>
-          <a:effectRef idx="2">
-            <a:schemeClr val="accent1"/>
-          </a:effectRef>
-          <a:fontRef idx="minor">
-            <a:schemeClr val="lt1"/>
-          </a:fontRef>
-        </p:style>
-        <p:txBody>
-          <a:bodyPr rtlCol="0" anchor="ctr"/>
-          <a:lstStyle/>
-          <a:p>
-            <a:pPr algn="ctr"/>
-            <a:endParaRPr/>
-          </a:p>
-        </p:txBody>
-      </p:sp>
-      <p:sp>
-        <p:nvSpPr>
-          <p:cNvPr id="3" name="TextBox 2"/>
-          <p:cNvSpPr txBox="1"/>
-          <p:nvPr/>
-        </p:nvSpPr>
-        <p:spPr>
-          <a:xfrm>
-            <a:off x="640080" y="347472"/>
-            <a:ext cx="3001143" cy="523220"/>
-          </a:xfrm>
-          <a:prstGeom prst="rect">
-            <a:avLst/>
-          </a:prstGeom>
-          <a:noFill/>
-        </p:spPr>
-        <p:txBody>
-          <a:bodyPr wrap="none">
-            <a:spAutoFit/>
-          </a:bodyPr>
-          <a:lstStyle/>
-          <a:p>
-            <a:r>
-              <a:rPr lang="pt-BR" sz="2800" b="1" dirty="0" smtClean="0">
-                <a:solidFill>
-                  <a:srgbClr val="F8FAFC"/>
-                </a:solidFill>
-                <a:latin typeface="Aptos Display"/>
-              </a:rPr>
-              <a:t>6</a:t>
             </a:r>
             <a:r>
               <a:rPr sz="2800" b="1" dirty="0" smtClean="0">
@@ -8255,7 +7746,7 @@
                   <a:srgbClr val="E2EAF4"/>
                 </a:solidFill>
                 <a:latin typeface="Aptos"/>
-                <a:hlinkClick r:id="rId3"/>
+                <a:hlinkClick r:id="rId3" action="ppaction://hlinkfile"/>
               </a:rPr>
               <a:t>vh-dev-fatec.github.io/</a:t>
             </a:r>
@@ -8265,7 +7756,7 @@
                   <a:srgbClr val="E2EAF4"/>
                 </a:solidFill>
                 <a:latin typeface="Aptos"/>
-                <a:hlinkClick r:id="rId3"/>
+                <a:hlinkClick r:id="rId3" action="ppaction://hlinkfile"/>
               </a:rPr>
               <a:t>torres-hanoi</a:t>
             </a:r>
@@ -8275,16 +7766,9 @@
                   <a:srgbClr val="E2EAF4"/>
                 </a:solidFill>
                 <a:latin typeface="Aptos"/>
-                <a:hlinkClick r:id="rId3"/>
               </a:rPr>
               <a:t>/</a:t>
             </a:r>
-            <a:endParaRPr sz="1800" dirty="0">
-              <a:solidFill>
-                <a:srgbClr val="E2EAF4"/>
-              </a:solidFill>
-              <a:latin typeface="Aptos"/>
-            </a:endParaRPr>
           </a:p>
         </p:txBody>
       </p:sp>
@@ -8778,34 +8262,16 @@
                 </a:solidFill>
                 <a:latin typeface="Aptos"/>
               </a:rPr>
-              <a:t>FATEC • Torre de </a:t>
-            </a:r>
-            <a:r>
-              <a:rPr sz="900" dirty="0" err="1">
+              <a:t>FATEC • Torre de Hanói   |   </a:t>
+            </a:r>
+            <a:r>
+              <a:rPr lang="pt-BR" sz="900" dirty="0">
                 <a:solidFill>
                   <a:srgbClr val="A0B4CD"/>
                 </a:solidFill>
                 <a:latin typeface="Aptos"/>
               </a:rPr>
-              <a:t>Hanói</a:t>
-            </a:r>
-            <a:r>
-              <a:rPr sz="900" dirty="0">
-                <a:solidFill>
-                  <a:srgbClr val="A0B4CD"/>
-                </a:solidFill>
-                <a:latin typeface="Aptos"/>
-              </a:rPr>
-              <a:t>   |   </a:t>
-            </a:r>
-            <a:r>
-              <a:rPr lang="pt-BR" sz="900" dirty="0">
-                <a:solidFill>
-                  <a:srgbClr val="A0B4CD"/>
-                </a:solidFill>
-                <a:latin typeface="Aptos"/>
-              </a:rPr>
-              <a:t>6</a:t>
+              <a:t>5</a:t>
             </a:r>
             <a:endParaRPr sz="900" dirty="0">
               <a:solidFill>

</xml_diff>